<commit_message>
feat(gpu-memory-reading-club): 重編為五堂課，主幹改成 SGLang 的問題導向
第三堂重編為「SGLang 單機篇」(24 頁)，主幹從 roofline 換成沿著 SGLang
遇到的問題走：①程式難平行 → 前端 DSL；②前綴重算 → 分頁 KV +
RadixAttention + continuous batching（含「RadixAttention vs
PagedAttention 是假對立」的澄清）；③輸出不可控 → Compressed FSM
（含與②的正交性紅線）；④CPU 成瓶頸 → zero-overhead scheduler /
CUDA Graph / chunked prefill；天花板：投機解碼·MTP、量化。

新增第四堂講稿「SGLang 多機篇」(問題 ⑤–⑧，投影片待補)：以經典分散式
系統的八類共同問題為開場框架，逐格對照 GPU 叢集哪些被規避／變形／放大，
並指出推論服務比訓練更靠近經典分散式系統那一端；含「KV 該搬還是該重算」
的壓軸推導構想。

新增第五堂「中國開源模型」(16 頁)：五個旋鈕（壓 KV／少算／少看／
一次多產／降精度）× 五個實驗室，含 MiniMax M1→M2→M3 反例兩頁與
「為什麼他們連 kernel 都開源」。

新增互動教具 serving_map.html：同一批請求在 naive / continuous batching /
paged KV / radix 前綴共用 / PD 分離 五種模式下的 GPU 時間軸、HBM 佔用、
有效 batch 與 roofline 位置。

一併納入先前未提交的第二堂（投影片、講稿、parallelism_map），
README 新增 §4.0 實際開講場次對照表，並修正 full_series 頁數 37→34。
</commit_message>
<xml_diff>
--- a/gpu-memory-reading-club/slides/full_series.pptx
+++ b/gpu-memory-reading-club/slides/full_series.pptx
@@ -18502,7 +18502,7 @@
                 <a:ea typeface="PingFang TC" pitchFamily="34" charset="-122"/>
                 <a:cs typeface="PingFang TC" pitchFamily="34" charset="-120"/>
               </a:rPr>
-              <a:t>講者：切出去打開玩具級 Transformer 地圖（T=5、d=6、2 heads——同構縮小版，含 encoder⟷decoder 全景與單一 matmul 的 L2/HBM 搬運）</a:t>
+              <a:t>講者：切出去打開玩具級 Transformer 地圖（T=5、d=6、2 heads——同構縮小版，decoder-only 全景與單一 matmul 的 L2/HBM 搬運）</a:t>
             </a:r>
             <a:endParaRPr lang="en-US" sz="1600" dirty="0"/>
           </a:p>
@@ -18557,8 +18557,8 @@
         </p:nvSpPr>
         <p:spPr>
           <a:xfrm>
-            <a:off x="544068" y="3794760"/>
-            <a:ext cx="1591056" cy="502920"/>
+            <a:off x="580644" y="3794760"/>
+            <a:ext cx="1371600" cy="502920"/>
           </a:xfrm>
           <a:prstGeom prst="roundRect">
             <a:avLst>
@@ -18584,8 +18584,8 @@
         </p:nvSpPr>
         <p:spPr>
           <a:xfrm>
-            <a:off x="544068" y="3794760"/>
-            <a:ext cx="1591056" cy="502920"/>
+            <a:off x="580644" y="3794760"/>
+            <a:ext cx="1371600" cy="502920"/>
           </a:xfrm>
           <a:prstGeom prst="rect">
             <a:avLst/>
@@ -18601,7 +18601,7 @@
               <a:buNone/>
             </a:pPr>
             <a:r>
-              <a:rPr lang="en-US" sz="1200" b="1" dirty="0">
+              <a:rPr lang="en-US" sz="1050" b="1" dirty="0">
                 <a:solidFill>
                   <a:srgbClr val="38BDF8"/>
                 </a:solidFill>
@@ -18609,9 +18609,9 @@
                 <a:ea typeface="Menlo" pitchFamily="34" charset="-122"/>
                 <a:cs typeface="Menlo" pitchFamily="34" charset="-120"/>
               </a:rPr>
-              <a:t>全景 Enc/Dec</a:t>
-            </a:r>
-            <a:endParaRPr lang="en-US" sz="1200" dirty="0"/>
+              <a:t>全景 decoder</a:t>
+            </a:r>
+            <a:endParaRPr lang="en-US" sz="1050" dirty="0"/>
           </a:p>
         </p:txBody>
       </p:sp>
@@ -18623,8 +18623,8 @@
         </p:nvSpPr>
         <p:spPr>
           <a:xfrm>
-            <a:off x="2171700" y="4046220"/>
-            <a:ext cx="237744" cy="0"/>
+            <a:off x="1988820" y="4046220"/>
+            <a:ext cx="164592" cy="0"/>
           </a:xfrm>
           <a:prstGeom prst="line">
             <a:avLst/>
@@ -18647,8 +18647,8 @@
         </p:nvSpPr>
         <p:spPr>
           <a:xfrm>
-            <a:off x="2446020" y="3794760"/>
-            <a:ext cx="1591056" cy="502920"/>
+            <a:off x="2189988" y="3794760"/>
+            <a:ext cx="1371600" cy="502920"/>
           </a:xfrm>
           <a:prstGeom prst="roundRect">
             <a:avLst>
@@ -18674,8 +18674,8 @@
         </p:nvSpPr>
         <p:spPr>
           <a:xfrm>
-            <a:off x="2446020" y="3794760"/>
-            <a:ext cx="1591056" cy="502920"/>
+            <a:off x="2189988" y="3794760"/>
+            <a:ext cx="1371600" cy="502920"/>
           </a:xfrm>
           <a:prstGeom prst="rect">
             <a:avLst/>
@@ -18691,7 +18691,7 @@
               <a:buNone/>
             </a:pPr>
             <a:r>
-              <a:rPr lang="en-US" sz="1200" b="1" dirty="0">
+              <a:rPr lang="en-US" sz="1050" b="1" dirty="0">
                 <a:solidFill>
                   <a:srgbClr val="38BDF8"/>
                 </a:solidFill>
@@ -18701,7 +18701,7 @@
               </a:rPr>
               <a:t>Block</a:t>
             </a:r>
-            <a:endParaRPr lang="en-US" sz="1200" dirty="0"/>
+            <a:endParaRPr lang="en-US" sz="1050" dirty="0"/>
           </a:p>
         </p:txBody>
       </p:sp>
@@ -18713,8 +18713,8 @@
         </p:nvSpPr>
         <p:spPr>
           <a:xfrm>
-            <a:off x="4073652" y="4046220"/>
-            <a:ext cx="237744" cy="0"/>
+            <a:off x="3598164" y="4046220"/>
+            <a:ext cx="164592" cy="0"/>
           </a:xfrm>
           <a:prstGeom prst="line">
             <a:avLst/>
@@ -18737,8 +18737,8 @@
         </p:nvSpPr>
         <p:spPr>
           <a:xfrm>
-            <a:off x="4347972" y="3794760"/>
-            <a:ext cx="1591056" cy="502920"/>
+            <a:off x="3799332" y="3794760"/>
+            <a:ext cx="1371600" cy="502920"/>
           </a:xfrm>
           <a:prstGeom prst="roundRect">
             <a:avLst>
@@ -18764,8 +18764,8 @@
         </p:nvSpPr>
         <p:spPr>
           <a:xfrm>
-            <a:off x="4347972" y="3794760"/>
-            <a:ext cx="1591056" cy="502920"/>
+            <a:off x="3799332" y="3794760"/>
+            <a:ext cx="1371600" cy="502920"/>
           </a:xfrm>
           <a:prstGeom prst="rect">
             <a:avLst/>
@@ -18781,7 +18781,7 @@
               <a:buNone/>
             </a:pPr>
             <a:r>
-              <a:rPr lang="en-US" sz="1200" b="1" dirty="0">
+              <a:rPr lang="en-US" sz="1050" b="1" dirty="0">
                 <a:solidFill>
                   <a:srgbClr val="38BDF8"/>
                 </a:solidFill>
@@ -18791,7 +18791,7 @@
               </a:rPr>
               <a:t>Attention</a:t>
             </a:r>
-            <a:endParaRPr lang="en-US" sz="1200" dirty="0"/>
+            <a:endParaRPr lang="en-US" sz="1050" dirty="0"/>
           </a:p>
         </p:txBody>
       </p:sp>
@@ -18803,8 +18803,8 @@
         </p:nvSpPr>
         <p:spPr>
           <a:xfrm>
-            <a:off x="5975604" y="4046220"/>
-            <a:ext cx="237744" cy="0"/>
+            <a:off x="5207508" y="4046220"/>
+            <a:ext cx="164592" cy="0"/>
           </a:xfrm>
           <a:prstGeom prst="line">
             <a:avLst/>
@@ -18827,8 +18827,8 @@
         </p:nvSpPr>
         <p:spPr>
           <a:xfrm>
-            <a:off x="6249924" y="3794760"/>
-            <a:ext cx="1591056" cy="502920"/>
+            <a:off x="5408676" y="3794760"/>
+            <a:ext cx="1371600" cy="502920"/>
           </a:xfrm>
           <a:prstGeom prst="roundRect">
             <a:avLst>
@@ -18854,8 +18854,8 @@
         </p:nvSpPr>
         <p:spPr>
           <a:xfrm>
-            <a:off x="6249924" y="3794760"/>
-            <a:ext cx="1591056" cy="502920"/>
+            <a:off x="5408676" y="3794760"/>
+            <a:ext cx="1371600" cy="502920"/>
           </a:xfrm>
           <a:prstGeom prst="rect">
             <a:avLst/>
@@ -18871,7 +18871,7 @@
               <a:buNone/>
             </a:pPr>
             <a:r>
-              <a:rPr lang="en-US" sz="1200" b="1" dirty="0">
+              <a:rPr lang="en-US" sz="1050" b="1" dirty="0">
                 <a:solidFill>
                   <a:srgbClr val="38BDF8"/>
                 </a:solidFill>
@@ -18881,7 +18881,7 @@
               </a:rPr>
               <a:t>Head</a:t>
             </a:r>
-            <a:endParaRPr lang="en-US" sz="1200" dirty="0"/>
+            <a:endParaRPr lang="en-US" sz="1050" dirty="0"/>
           </a:p>
         </p:txBody>
       </p:sp>
@@ -18893,8 +18893,8 @@
         </p:nvSpPr>
         <p:spPr>
           <a:xfrm>
-            <a:off x="7877556" y="4046220"/>
-            <a:ext cx="237744" cy="0"/>
+            <a:off x="6816852" y="4046220"/>
+            <a:ext cx="164592" cy="0"/>
           </a:xfrm>
           <a:prstGeom prst="line">
             <a:avLst/>
@@ -18917,8 +18917,8 @@
         </p:nvSpPr>
         <p:spPr>
           <a:xfrm>
-            <a:off x="8151876" y="3794760"/>
-            <a:ext cx="1591056" cy="502920"/>
+            <a:off x="7018020" y="3794760"/>
+            <a:ext cx="1371600" cy="502920"/>
           </a:xfrm>
           <a:prstGeom prst="roundRect">
             <a:avLst>
@@ -18944,8 +18944,8 @@
         </p:nvSpPr>
         <p:spPr>
           <a:xfrm>
-            <a:off x="8151876" y="3794760"/>
-            <a:ext cx="1591056" cy="502920"/>
+            <a:off x="7018020" y="3794760"/>
+            <a:ext cx="1371600" cy="502920"/>
           </a:xfrm>
           <a:prstGeom prst="rect">
             <a:avLst/>
@@ -18961,7 +18961,7 @@
               <a:buNone/>
             </a:pPr>
             <a:r>
-              <a:rPr lang="en-US" sz="1200" b="1" dirty="0">
+              <a:rPr lang="en-US" sz="1050" b="1" dirty="0">
                 <a:solidFill>
                   <a:srgbClr val="38BDF8"/>
                 </a:solidFill>
@@ -18971,7 +18971,7 @@
               </a:rPr>
               <a:t>計算子</a:t>
             </a:r>
-            <a:endParaRPr lang="en-US" sz="1200" dirty="0"/>
+            <a:endParaRPr lang="en-US" sz="1050" dirty="0"/>
           </a:p>
         </p:txBody>
       </p:sp>
@@ -18983,8 +18983,8 @@
         </p:nvSpPr>
         <p:spPr>
           <a:xfrm>
-            <a:off x="9779508" y="4046220"/>
-            <a:ext cx="237744" cy="0"/>
+            <a:off x="8426196" y="4046220"/>
+            <a:ext cx="164592" cy="0"/>
           </a:xfrm>
           <a:prstGeom prst="line">
             <a:avLst/>
@@ -19007,8 +19007,98 @@
         </p:nvSpPr>
         <p:spPr>
           <a:xfrm>
-            <a:off x="10053828" y="3794760"/>
-            <a:ext cx="1591056" cy="502920"/>
+            <a:off x="8627364" y="3794760"/>
+            <a:ext cx="1371600" cy="502920"/>
+          </a:xfrm>
+          <a:prstGeom prst="roundRect">
+            <a:avLst>
+              <a:gd name="adj" fmla="val 14545"/>
+            </a:avLst>
+          </a:prstGeom>
+          <a:solidFill>
+            <a:srgbClr val="10455F"/>
+          </a:solidFill>
+          <a:ln w="15240">
+            <a:solidFill>
+              <a:srgbClr val="38BDF8"/>
+            </a:solidFill>
+            <a:prstDash val="solid"/>
+          </a:ln>
+        </p:spPr>
+      </p:sp>
+      <p:sp>
+        <p:nvSpPr>
+          <p:cNvPr id="22" name="Text 20"/>
+          <p:cNvSpPr/>
+          <p:nvPr/>
+        </p:nvSpPr>
+        <p:spPr>
+          <a:xfrm>
+            <a:off x="8627364" y="3794760"/>
+            <a:ext cx="1371600" cy="502920"/>
+          </a:xfrm>
+          <a:prstGeom prst="rect">
+            <a:avLst/>
+          </a:prstGeom>
+          <a:noFill/>
+          <a:ln/>
+        </p:spPr>
+        <p:txBody>
+          <a:bodyPr wrap="square" lIns="0" tIns="0" rIns="0" bIns="0" rtlCol="0" anchor="ctr"/>
+          <a:lstStyle/>
+          <a:p>
+            <a:pPr algn="ctr" indent="0" marL="0">
+              <a:buNone/>
+            </a:pPr>
+            <a:r>
+              <a:rPr lang="en-US" sz="1050" b="1" dirty="0">
+                <a:solidFill>
+                  <a:srgbClr val="38BDF8"/>
+                </a:solidFill>
+                <a:latin typeface="Menlo" pitchFamily="34" charset="0"/>
+                <a:ea typeface="Menlo" pitchFamily="34" charset="-122"/>
+                <a:cs typeface="Menlo" pitchFamily="34" charset="-120"/>
+              </a:rPr>
+              <a:t>FlashAttn</a:t>
+            </a:r>
+            <a:endParaRPr lang="en-US" sz="1050" dirty="0"/>
+          </a:p>
+        </p:txBody>
+      </p:sp>
+      <p:sp>
+        <p:nvSpPr>
+          <p:cNvPr id="23" name="Shape 21"/>
+          <p:cNvSpPr/>
+          <p:nvPr/>
+        </p:nvSpPr>
+        <p:spPr>
+          <a:xfrm>
+            <a:off x="10035540" y="4046220"/>
+            <a:ext cx="164592" cy="0"/>
+          </a:xfrm>
+          <a:prstGeom prst="line">
+            <a:avLst/>
+          </a:prstGeom>
+          <a:noFill/>
+          <a:ln w="25400">
+            <a:solidFill>
+              <a:srgbClr val="5C7299"/>
+            </a:solidFill>
+            <a:prstDash val="solid"/>
+            <a:tailEnd type="triangle"/>
+          </a:ln>
+        </p:spPr>
+      </p:sp>
+      <p:sp>
+        <p:nvSpPr>
+          <p:cNvPr id="24" name="Shape 22"/>
+          <p:cNvSpPr/>
+          <p:nvPr/>
+        </p:nvSpPr>
+        <p:spPr>
+          <a:xfrm>
+            <a:off x="10236708" y="3794760"/>
+            <a:ext cx="1371600" cy="502920"/>
           </a:xfrm>
           <a:prstGeom prst="roundRect">
             <a:avLst>
@@ -19028,14 +19118,14 @@
       </p:sp>
       <p:sp>
         <p:nvSpPr>
-          <p:cNvPr id="22" name="Text 20"/>
-          <p:cNvSpPr/>
-          <p:nvPr/>
-        </p:nvSpPr>
-        <p:spPr>
-          <a:xfrm>
-            <a:off x="10053828" y="3794760"/>
-            <a:ext cx="1591056" cy="502920"/>
+          <p:cNvPr id="25" name="Text 23"/>
+          <p:cNvSpPr/>
+          <p:nvPr/>
+        </p:nvSpPr>
+        <p:spPr>
+          <a:xfrm>
+            <a:off x="10236708" y="3794760"/>
+            <a:ext cx="1371600" cy="502920"/>
           </a:xfrm>
           <a:prstGeom prst="rect">
             <a:avLst/>
@@ -19051,7 +19141,7 @@
               <a:buNone/>
             </a:pPr>
             <a:r>
-              <a:rPr lang="en-US" sz="1200" b="1" dirty="0">
+              <a:rPr lang="en-US" sz="1050" b="1" dirty="0">
                 <a:solidFill>
                   <a:srgbClr val="F59E0B"/>
                 </a:solidFill>
@@ -19061,13 +19151,13 @@
               </a:rPr>
               <a:t>硬體 3 機</a:t>
             </a:r>
-            <a:endParaRPr lang="en-US" sz="1200" dirty="0"/>
-          </a:p>
-        </p:txBody>
-      </p:sp>
-      <p:sp>
-        <p:nvSpPr>
-          <p:cNvPr id="23" name="Text 21"/>
+            <a:endParaRPr lang="en-US" sz="1050" dirty="0"/>
+          </a:p>
+        </p:txBody>
+      </p:sp>
+      <p:sp>
+        <p:nvSpPr>
+          <p:cNvPr id="26" name="Text 24"/>
           <p:cNvSpPr/>
           <p:nvPr/>
         </p:nvSpPr>
@@ -19190,7 +19280,7 @@
       </p:sp>
       <p:sp>
         <p:nvSpPr>
-          <p:cNvPr id="24" name="Text 22"/>
+          <p:cNvPr id="27" name="Text 25"/>
           <p:cNvSpPr/>
           <p:nvPr/>
         </p:nvSpPr>
@@ -19221,7 +19311,7 @@
                 <a:ea typeface="PingFang TC" pitchFamily="34" charset="-122"/>
                 <a:cs typeface="PingFang TC" pitchFamily="34" charset="-120"/>
               </a:rPr>
-              <a:t>建議動線：全景（encoder→memory M→decoder cross）→ Block → Attention（分叉＝平行軸）→ Head 看矩陣 → 計算子：一個 matmul 的 L2⟷HBM 搬運 → 硬體層 GPU/TPU/Groq；全程配 T/P/D 看 compute-bound→memory-bound、KV cache 串流 → 回來接下一頁</a:t>
+              <a:t>建議動線：全景（decoder-only）→ Block → Attention（分叉＝平行軸）→ Head 看矩陣 → 計算子：matmul 的 L2⟷HBM 搬運 → FlashAttention（線上 softmax，←/→ 逐步看 S 怎麼不落 HBM）→ 硬體層 GPU/TPU/Groq；配 T/P/D 看 compute-bound→memory-bound</a:t>
             </a:r>
             <a:endParaRPr lang="en-US" sz="1100" dirty="0"/>
           </a:p>
@@ -19229,7 +19319,7 @@
       </p:sp>
       <p:sp>
         <p:nvSpPr>
-          <p:cNvPr id="25" name="Text 23"/>
+          <p:cNvPr id="28" name="Text 26"/>
           <p:cNvSpPr/>
           <p:nvPr/>
         </p:nvSpPr>
@@ -19268,7 +19358,7 @@
       </p:sp>
       <p:sp>
         <p:nvSpPr>
-          <p:cNvPr id="26" name="Text 24"/>
+          <p:cNvPr id="29" name="Text 27"/>
           <p:cNvSpPr/>
           <p:nvPr/>
         </p:nvSpPr>

</xml_diff>